<commit_message>
report and slides fix grammer, update gantt chart and few revisions
</commit_message>
<xml_diff>
--- a/Documentation/Weekly Report/week13/CMSC-4920-Week13-Group2.pptx
+++ b/Documentation/Weekly Report/week13/CMSC-4920-Week13-Group2.pptx
@@ -122,268 +122,8 @@
 </p:presentation>
 </file>
 
-<file path=ppt/revisionInfo.xml><?xml version="1.0" encoding="utf-8"?>
-<p1510:revInfo xmlns:a="http://schemas.openxmlformats.org/drawingml/2006/main" xmlns:r="http://schemas.openxmlformats.org/officeDocument/2006/relationships" xmlns:p1510="http://schemas.microsoft.com/office/powerpoint/2015/10/main">
-  <p1510:revLst>
-    <p1510:client id="{AA469995-2C85-4A2B-B8F3-46D2FC896B39}" v="1" dt="2026-04-05T12:44:26.228"/>
-  </p1510:revLst>
-</p1510:revInfo>
-</file>
-
 <file path=ppt/changesInfos/changesInfo1.xml><?xml version="1.0" encoding="utf-8"?>
 <pc:chgInfo xmlns:a="http://schemas.openxmlformats.org/drawingml/2006/main" xmlns:r="http://schemas.openxmlformats.org/officeDocument/2006/relationships" xmlns:ac="http://schemas.microsoft.com/office/drawing/2013/main/command" xmlns:pc="http://schemas.microsoft.com/office/powerpoint/2013/main/command">
-  <pc:docChgLst>
-    <pc:chgData name="Margo Bonal" userId="18c9fa0f-b53d-478b-9dc0-6ad88786c19f" providerId="ADAL" clId="{93D479E5-F67F-4B8A-A78F-A0B574A116B6}"/>
-    <pc:docChg chg="undo custSel addSld delSld modSld">
-      <pc:chgData name="Margo Bonal" userId="18c9fa0f-b53d-478b-9dc0-6ad88786c19f" providerId="ADAL" clId="{93D479E5-F67F-4B8A-A78F-A0B574A116B6}" dt="2026-04-05T23:08:31.942" v="1065" actId="20577"/>
-      <pc:docMkLst>
-        <pc:docMk/>
-      </pc:docMkLst>
-      <pc:sldChg chg="modSp mod">
-        <pc:chgData name="Margo Bonal" userId="18c9fa0f-b53d-478b-9dc0-6ad88786c19f" providerId="ADAL" clId="{93D479E5-F67F-4B8A-A78F-A0B574A116B6}" dt="2026-04-05T23:08:31.942" v="1065" actId="20577"/>
-        <pc:sldMkLst>
-          <pc:docMk/>
-          <pc:sldMk cId="2561402868" sldId="264"/>
-        </pc:sldMkLst>
-        <pc:spChg chg="mod">
-          <ac:chgData name="Margo Bonal" userId="18c9fa0f-b53d-478b-9dc0-6ad88786c19f" providerId="ADAL" clId="{93D479E5-F67F-4B8A-A78F-A0B574A116B6}" dt="2026-03-21T14:21:56.751" v="935" actId="27636"/>
-          <ac:spMkLst>
-            <pc:docMk/>
-            <pc:sldMk cId="2561402868" sldId="264"/>
-            <ac:spMk id="9" creationId="{D6D36DC8-D9BF-8C26-69EA-ED89E34DB644}"/>
-          </ac:spMkLst>
-        </pc:spChg>
-        <pc:graphicFrameChg chg="mod modGraphic">
-          <ac:chgData name="Margo Bonal" userId="18c9fa0f-b53d-478b-9dc0-6ad88786c19f" providerId="ADAL" clId="{93D479E5-F67F-4B8A-A78F-A0B574A116B6}" dt="2026-04-05T23:08:31.942" v="1065" actId="20577"/>
-          <ac:graphicFrameMkLst>
-            <pc:docMk/>
-            <pc:sldMk cId="2561402868" sldId="264"/>
-            <ac:graphicFrameMk id="27" creationId="{D6B93F0B-FEB0-EDAB-CFE1-A57DEFE97FCD}"/>
-          </ac:graphicFrameMkLst>
-        </pc:graphicFrameChg>
-      </pc:sldChg>
-      <pc:sldChg chg="delSp modSp mod">
-        <pc:chgData name="Margo Bonal" userId="18c9fa0f-b53d-478b-9dc0-6ad88786c19f" providerId="ADAL" clId="{93D479E5-F67F-4B8A-A78F-A0B574A116B6}" dt="2026-03-30T01:10:14.587" v="969" actId="14100"/>
-        <pc:sldMkLst>
-          <pc:docMk/>
-          <pc:sldMk cId="2428741132" sldId="265"/>
-        </pc:sldMkLst>
-        <pc:spChg chg="mod">
-          <ac:chgData name="Margo Bonal" userId="18c9fa0f-b53d-478b-9dc0-6ad88786c19f" providerId="ADAL" clId="{93D479E5-F67F-4B8A-A78F-A0B574A116B6}" dt="2026-03-30T01:10:14.587" v="969" actId="14100"/>
-          <ac:spMkLst>
-            <pc:docMk/>
-            <pc:sldMk cId="2428741132" sldId="265"/>
-            <ac:spMk id="8" creationId="{7A067979-B2B3-BD33-28AB-42AF2BBE1977}"/>
-          </ac:spMkLst>
-        </pc:spChg>
-      </pc:sldChg>
-      <pc:sldChg chg="modSp mod">
-        <pc:chgData name="Margo Bonal" userId="18c9fa0f-b53d-478b-9dc0-6ad88786c19f" providerId="ADAL" clId="{93D479E5-F67F-4B8A-A78F-A0B574A116B6}" dt="2026-03-21T14:09:48.188" v="518" actId="20577"/>
-        <pc:sldMkLst>
-          <pc:docMk/>
-          <pc:sldMk cId="3526335932" sldId="266"/>
-        </pc:sldMkLst>
-        <pc:spChg chg="mod">
-          <ac:chgData name="Margo Bonal" userId="18c9fa0f-b53d-478b-9dc0-6ad88786c19f" providerId="ADAL" clId="{93D479E5-F67F-4B8A-A78F-A0B574A116B6}" dt="2026-03-21T14:09:48.188" v="518" actId="20577"/>
-          <ac:spMkLst>
-            <pc:docMk/>
-            <pc:sldMk cId="3526335932" sldId="266"/>
-            <ac:spMk id="3" creationId="{CCDEAB36-867D-95B6-8834-F42C5B9259D0}"/>
-          </ac:spMkLst>
-        </pc:spChg>
-        <pc:spChg chg="mod">
-          <ac:chgData name="Margo Bonal" userId="18c9fa0f-b53d-478b-9dc0-6ad88786c19f" providerId="ADAL" clId="{93D479E5-F67F-4B8A-A78F-A0B574A116B6}" dt="2026-03-21T14:09:45.490" v="517" actId="20577"/>
-          <ac:spMkLst>
-            <pc:docMk/>
-            <pc:sldMk cId="3526335932" sldId="266"/>
-            <ac:spMk id="4" creationId="{86ED9EE4-56A8-6AFD-BE9A-A35D2ABC59A0}"/>
-          </ac:spMkLst>
-        </pc:spChg>
-      </pc:sldChg>
-      <pc:sldChg chg="addSp modSp new mod setBg">
-        <pc:chgData name="Margo Bonal" userId="18c9fa0f-b53d-478b-9dc0-6ad88786c19f" providerId="ADAL" clId="{93D479E5-F67F-4B8A-A78F-A0B574A116B6}" dt="2026-04-05T12:47:09.188" v="1035" actId="20577"/>
-        <pc:sldMkLst>
-          <pc:docMk/>
-          <pc:sldMk cId="4265846240" sldId="273"/>
-        </pc:sldMkLst>
-        <pc:spChg chg="mod">
-          <ac:chgData name="Margo Bonal" userId="18c9fa0f-b53d-478b-9dc0-6ad88786c19f" providerId="ADAL" clId="{93D479E5-F67F-4B8A-A78F-A0B574A116B6}" dt="2026-04-05T12:46:30.580" v="1021" actId="1076"/>
-          <ac:spMkLst>
-            <pc:docMk/>
-            <pc:sldMk cId="4265846240" sldId="273"/>
-            <ac:spMk id="2" creationId="{DF831928-2BB9-C45B-9B78-9B9C5E78C657}"/>
-          </ac:spMkLst>
-        </pc:spChg>
-        <pc:spChg chg="mod">
-          <ac:chgData name="Margo Bonal" userId="18c9fa0f-b53d-478b-9dc0-6ad88786c19f" providerId="ADAL" clId="{93D479E5-F67F-4B8A-A78F-A0B574A116B6}" dt="2026-04-05T12:47:09.188" v="1035" actId="20577"/>
-          <ac:spMkLst>
-            <pc:docMk/>
-            <pc:sldMk cId="4265846240" sldId="273"/>
-            <ac:spMk id="3" creationId="{A2C8BFE2-FC98-104F-F2E2-CE52A9F6721A}"/>
-          </ac:spMkLst>
-        </pc:spChg>
-        <pc:spChg chg="add">
-          <ac:chgData name="Margo Bonal" userId="18c9fa0f-b53d-478b-9dc0-6ad88786c19f" providerId="ADAL" clId="{93D479E5-F67F-4B8A-A78F-A0B574A116B6}" dt="2026-04-05T12:46:25.011" v="1017" actId="26606"/>
-          <ac:spMkLst>
-            <pc:docMk/>
-            <pc:sldMk cId="4265846240" sldId="273"/>
-            <ac:spMk id="8" creationId="{46F1F2C8-798B-4CCE-A851-94AFAF350BED}"/>
-          </ac:spMkLst>
-        </pc:spChg>
-        <pc:spChg chg="add">
-          <ac:chgData name="Margo Bonal" userId="18c9fa0f-b53d-478b-9dc0-6ad88786c19f" providerId="ADAL" clId="{93D479E5-F67F-4B8A-A78F-A0B574A116B6}" dt="2026-04-05T12:46:25.011" v="1017" actId="26606"/>
-          <ac:spMkLst>
-            <pc:docMk/>
-            <pc:sldMk cId="4265846240" sldId="273"/>
-            <ac:spMk id="10" creationId="{755E9CD0-04B0-4A3C-B291-AD913379C713}"/>
-          </ac:spMkLst>
-        </pc:spChg>
-        <pc:spChg chg="add">
-          <ac:chgData name="Margo Bonal" userId="18c9fa0f-b53d-478b-9dc0-6ad88786c19f" providerId="ADAL" clId="{93D479E5-F67F-4B8A-A78F-A0B574A116B6}" dt="2026-04-05T12:46:25.011" v="1017" actId="26606"/>
-          <ac:spMkLst>
-            <pc:docMk/>
-            <pc:sldMk cId="4265846240" sldId="273"/>
-            <ac:spMk id="12" creationId="{1DD8BF3B-6066-418C-8D1A-75C5E396FC04}"/>
-          </ac:spMkLst>
-        </pc:spChg>
-        <pc:spChg chg="add">
-          <ac:chgData name="Margo Bonal" userId="18c9fa0f-b53d-478b-9dc0-6ad88786c19f" providerId="ADAL" clId="{93D479E5-F67F-4B8A-A78F-A0B574A116B6}" dt="2026-04-05T12:46:25.011" v="1017" actId="26606"/>
-          <ac:spMkLst>
-            <pc:docMk/>
-            <pc:sldMk cId="4265846240" sldId="273"/>
-            <ac:spMk id="14" creationId="{80BC66F9-7A74-4286-AD22-1174052CC22C}"/>
-          </ac:spMkLst>
-        </pc:spChg>
-        <pc:spChg chg="add">
-          <ac:chgData name="Margo Bonal" userId="18c9fa0f-b53d-478b-9dc0-6ad88786c19f" providerId="ADAL" clId="{93D479E5-F67F-4B8A-A78F-A0B574A116B6}" dt="2026-04-05T12:46:25.011" v="1017" actId="26606"/>
-          <ac:spMkLst>
-            <pc:docMk/>
-            <pc:sldMk cId="4265846240" sldId="273"/>
-            <ac:spMk id="16" creationId="{D8142CC3-2B5C-48E6-9DF0-6C8ACBAF23EF}"/>
-          </ac:spMkLst>
-        </pc:spChg>
-        <pc:spChg chg="add">
-          <ac:chgData name="Margo Bonal" userId="18c9fa0f-b53d-478b-9dc0-6ad88786c19f" providerId="ADAL" clId="{93D479E5-F67F-4B8A-A78F-A0B574A116B6}" dt="2026-04-05T12:46:25.011" v="1017" actId="26606"/>
-          <ac:spMkLst>
-            <pc:docMk/>
-            <pc:sldMk cId="4265846240" sldId="273"/>
-            <ac:spMk id="20" creationId="{46A89C79-8EF3-4AF9-B3D9-59A883F41C83}"/>
-          </ac:spMkLst>
-        </pc:spChg>
-        <pc:spChg chg="add">
-          <ac:chgData name="Margo Bonal" userId="18c9fa0f-b53d-478b-9dc0-6ad88786c19f" providerId="ADAL" clId="{93D479E5-F67F-4B8A-A78F-A0B574A116B6}" dt="2026-04-05T12:46:25.011" v="1017" actId="26606"/>
-          <ac:spMkLst>
-            <pc:docMk/>
-            <pc:sldMk cId="4265846240" sldId="273"/>
-            <ac:spMk id="22" creationId="{EFE5CE34-4543-42E5-B82C-1F3D12422CDD}"/>
-          </ac:spMkLst>
-        </pc:spChg>
-        <pc:spChg chg="add">
-          <ac:chgData name="Margo Bonal" userId="18c9fa0f-b53d-478b-9dc0-6ad88786c19f" providerId="ADAL" clId="{93D479E5-F67F-4B8A-A78F-A0B574A116B6}" dt="2026-04-05T12:46:25.011" v="1017" actId="26606"/>
-          <ac:spMkLst>
-            <pc:docMk/>
-            <pc:sldMk cId="4265846240" sldId="273"/>
-            <ac:spMk id="24" creationId="{72AF41FE-63D7-4695-81D2-66D2510E4486}"/>
-          </ac:spMkLst>
-        </pc:spChg>
-      </pc:sldChg>
-      <pc:sldChg chg="addSp delSp modSp new mod setBg">
-        <pc:chgData name="Margo Bonal" userId="18c9fa0f-b53d-478b-9dc0-6ad88786c19f" providerId="ADAL" clId="{93D479E5-F67F-4B8A-A78F-A0B574A116B6}" dt="2026-04-05T12:47:40.738" v="1057" actId="26606"/>
-        <pc:sldMkLst>
-          <pc:docMk/>
-          <pc:sldMk cId="1221735276" sldId="274"/>
-        </pc:sldMkLst>
-        <pc:spChg chg="mod">
-          <ac:chgData name="Margo Bonal" userId="18c9fa0f-b53d-478b-9dc0-6ad88786c19f" providerId="ADAL" clId="{93D479E5-F67F-4B8A-A78F-A0B574A116B6}" dt="2026-04-05T12:47:40.738" v="1057" actId="26606"/>
-          <ac:spMkLst>
-            <pc:docMk/>
-            <pc:sldMk cId="1221735276" sldId="274"/>
-            <ac:spMk id="2" creationId="{093A71C4-DFA5-A2AF-DF66-B2209A4E3DCD}"/>
-          </ac:spMkLst>
-        </pc:spChg>
-        <pc:spChg chg="del">
-          <ac:chgData name="Margo Bonal" userId="18c9fa0f-b53d-478b-9dc0-6ad88786c19f" providerId="ADAL" clId="{93D479E5-F67F-4B8A-A78F-A0B574A116B6}" dt="2026-04-05T12:47:31.645" v="1054" actId="478"/>
-          <ac:spMkLst>
-            <pc:docMk/>
-            <pc:sldMk cId="1221735276" sldId="274"/>
-            <ac:spMk id="3" creationId="{DA278A54-5E95-6089-F3D9-1FFDB3D98524}"/>
-          </ac:spMkLst>
-        </pc:spChg>
-        <pc:spChg chg="add del">
-          <ac:chgData name="Margo Bonal" userId="18c9fa0f-b53d-478b-9dc0-6ad88786c19f" providerId="ADAL" clId="{93D479E5-F67F-4B8A-A78F-A0B574A116B6}" dt="2026-04-05T12:47:40.714" v="1056" actId="26606"/>
-          <ac:spMkLst>
-            <pc:docMk/>
-            <pc:sldMk cId="1221735276" sldId="274"/>
-            <ac:spMk id="7" creationId="{289ED1AA-8684-4D37-B208-8777E1A7780D}"/>
-          </ac:spMkLst>
-        </pc:spChg>
-        <pc:spChg chg="add del">
-          <ac:chgData name="Margo Bonal" userId="18c9fa0f-b53d-478b-9dc0-6ad88786c19f" providerId="ADAL" clId="{93D479E5-F67F-4B8A-A78F-A0B574A116B6}" dt="2026-04-05T12:47:40.714" v="1056" actId="26606"/>
-          <ac:spMkLst>
-            <pc:docMk/>
-            <pc:sldMk cId="1221735276" sldId="274"/>
-            <ac:spMk id="9" creationId="{4180E01B-B1F4-437C-807D-1C930718EE64}"/>
-          </ac:spMkLst>
-        </pc:spChg>
-        <pc:spChg chg="add del">
-          <ac:chgData name="Margo Bonal" userId="18c9fa0f-b53d-478b-9dc0-6ad88786c19f" providerId="ADAL" clId="{93D479E5-F67F-4B8A-A78F-A0B574A116B6}" dt="2026-04-05T12:47:40.714" v="1056" actId="26606"/>
-          <ac:spMkLst>
-            <pc:docMk/>
-            <pc:sldMk cId="1221735276" sldId="274"/>
-            <ac:spMk id="11" creationId="{41F77738-2AF0-4750-A0C7-F97C2C17590E}"/>
-          </ac:spMkLst>
-        </pc:spChg>
-        <pc:spChg chg="add">
-          <ac:chgData name="Margo Bonal" userId="18c9fa0f-b53d-478b-9dc0-6ad88786c19f" providerId="ADAL" clId="{93D479E5-F67F-4B8A-A78F-A0B574A116B6}" dt="2026-04-05T12:47:40.738" v="1057" actId="26606"/>
-          <ac:spMkLst>
-            <pc:docMk/>
-            <pc:sldMk cId="1221735276" sldId="274"/>
-            <ac:spMk id="13" creationId="{48E405C9-94BE-41DA-928C-DEC9A8550E9F}"/>
-          </ac:spMkLst>
-        </pc:spChg>
-        <pc:spChg chg="add">
-          <ac:chgData name="Margo Bonal" userId="18c9fa0f-b53d-478b-9dc0-6ad88786c19f" providerId="ADAL" clId="{93D479E5-F67F-4B8A-A78F-A0B574A116B6}" dt="2026-04-05T12:47:40.738" v="1057" actId="26606"/>
-          <ac:spMkLst>
-            <pc:docMk/>
-            <pc:sldMk cId="1221735276" sldId="274"/>
-            <ac:spMk id="14" creationId="{D278ADA9-6383-4BDD-80D2-8899A402687B}"/>
-          </ac:spMkLst>
-        </pc:spChg>
-        <pc:spChg chg="add">
-          <ac:chgData name="Margo Bonal" userId="18c9fa0f-b53d-478b-9dc0-6ad88786c19f" providerId="ADAL" clId="{93D479E5-F67F-4B8A-A78F-A0B574A116B6}" dt="2026-04-05T12:47:40.738" v="1057" actId="26606"/>
-          <ac:spMkLst>
-            <pc:docMk/>
-            <pc:sldMk cId="1221735276" sldId="274"/>
-            <ac:spMk id="15" creationId="{D2091A72-D5BB-42AC-8FD3-F7747D90861E}"/>
-          </ac:spMkLst>
-        </pc:spChg>
-        <pc:spChg chg="add">
-          <ac:chgData name="Margo Bonal" userId="18c9fa0f-b53d-478b-9dc0-6ad88786c19f" providerId="ADAL" clId="{93D479E5-F67F-4B8A-A78F-A0B574A116B6}" dt="2026-04-05T12:47:40.738" v="1057" actId="26606"/>
-          <ac:spMkLst>
-            <pc:docMk/>
-            <pc:sldMk cId="1221735276" sldId="274"/>
-            <ac:spMk id="16" creationId="{484B7147-B0F6-40ED-B5A2-FF72BC8198B6}"/>
-          </ac:spMkLst>
-        </pc:spChg>
-        <pc:spChg chg="add">
-          <ac:chgData name="Margo Bonal" userId="18c9fa0f-b53d-478b-9dc0-6ad88786c19f" providerId="ADAL" clId="{93D479E5-F67F-4B8A-A78F-A0B574A116B6}" dt="2026-04-05T12:47:40.738" v="1057" actId="26606"/>
-          <ac:spMkLst>
-            <pc:docMk/>
-            <pc:sldMk cId="1221735276" sldId="274"/>
-            <ac:spMk id="17" creationId="{6ED12BFC-A737-46AF-8411-481112D54B0C}"/>
-          </ac:spMkLst>
-        </pc:spChg>
-        <pc:spChg chg="add">
-          <ac:chgData name="Margo Bonal" userId="18c9fa0f-b53d-478b-9dc0-6ad88786c19f" providerId="ADAL" clId="{93D479E5-F67F-4B8A-A78F-A0B574A116B6}" dt="2026-04-05T12:47:40.738" v="1057" actId="26606"/>
-          <ac:spMkLst>
-            <pc:docMk/>
-            <pc:sldMk cId="1221735276" sldId="274"/>
-            <ac:spMk id="18" creationId="{B36D2DE0-0628-4A9A-A59D-7BA8B5EB3022}"/>
-          </ac:spMkLst>
-        </pc:spChg>
-      </pc:sldChg>
-    </pc:docChg>
-  </pc:docChgLst>
   <pc:docChgLst>
     <pc:chgData name="John Gerega" userId="bd3e1e46fb6a714b" providerId="LiveId" clId="{45F0C402-C550-4C82-B31D-5B32217A5E94}"/>
     <pc:docChg chg="undo custSel addSld delSld modSld">
@@ -397,14 +137,6 @@
           <pc:docMk/>
           <pc:sldMk cId="2561402868" sldId="264"/>
         </pc:sldMkLst>
-        <pc:spChg chg="mod">
-          <ac:chgData name="John Gerega" userId="bd3e1e46fb6a714b" providerId="LiveId" clId="{45F0C402-C550-4C82-B31D-5B32217A5E94}" dt="2026-03-09T00:42:55.862" v="1001" actId="20577"/>
-          <ac:spMkLst>
-            <pc:docMk/>
-            <pc:sldMk cId="2561402868" sldId="264"/>
-            <ac:spMk id="9" creationId="{D6D36DC8-D9BF-8C26-69EA-ED89E34DB644}"/>
-          </ac:spMkLst>
-        </pc:spChg>
         <pc:graphicFrameChg chg="mod modGraphic">
           <ac:chgData name="John Gerega" userId="bd3e1e46fb6a714b" providerId="LiveId" clId="{45F0C402-C550-4C82-B31D-5B32217A5E94}" dt="2026-03-29T13:00:56.525" v="2636" actId="20577"/>
           <ac:graphicFrameMkLst>
@@ -444,14 +176,6 @@
           </ac:spMkLst>
         </pc:spChg>
         <pc:spChg chg="mod">
-          <ac:chgData name="John Gerega" userId="bd3e1e46fb6a714b" providerId="LiveId" clId="{45F0C402-C550-4C82-B31D-5B32217A5E94}" dt="2026-03-09T00:42:40.261" v="1000" actId="20577"/>
-          <ac:spMkLst>
-            <pc:docMk/>
-            <pc:sldMk cId="3526335932" sldId="266"/>
-            <ac:spMk id="3" creationId="{CCDEAB36-867D-95B6-8834-F42C5B9259D0}"/>
-          </ac:spMkLst>
-        </pc:spChg>
-        <pc:spChg chg="mod">
           <ac:chgData name="John Gerega" userId="bd3e1e46fb6a714b" providerId="LiveId" clId="{45F0C402-C550-4C82-B31D-5B32217A5E94}" dt="2026-04-04T21:43:44.510" v="3160" actId="20577"/>
           <ac:spMkLst>
             <pc:docMk/>
@@ -468,42 +192,106 @@
           </ac:spMkLst>
         </pc:spChg>
       </pc:sldChg>
-      <pc:sldChg chg="new del">
-        <pc:chgData name="John Gerega" userId="bd3e1e46fb6a714b" providerId="LiveId" clId="{45F0C402-C550-4C82-B31D-5B32217A5E94}" dt="2026-04-04T21:41:51.178" v="2647" actId="47"/>
+    </pc:docChg>
+  </pc:docChgLst>
+  <pc:docChgLst>
+    <pc:chgData name="Margo Bonal" userId="18c9fa0f-b53d-478b-9dc0-6ad88786c19f" providerId="ADAL" clId="{93D479E5-F67F-4B8A-A78F-A0B574A116B6}"/>
+    <pc:docChg chg="undo custSel addSld delSld modSld">
+      <pc:chgData name="Margo Bonal" userId="18c9fa0f-b53d-478b-9dc0-6ad88786c19f" providerId="ADAL" clId="{93D479E5-F67F-4B8A-A78F-A0B574A116B6}" dt="2026-04-12T10:51:28.860" v="1342" actId="14100"/>
+      <pc:docMkLst>
+        <pc:docMk/>
+      </pc:docMkLst>
+      <pc:sldChg chg="addSp delSp modSp mod">
+        <pc:chgData name="Margo Bonal" userId="18c9fa0f-b53d-478b-9dc0-6ad88786c19f" providerId="ADAL" clId="{93D479E5-F67F-4B8A-A78F-A0B574A116B6}" dt="2026-04-12T10:51:28.860" v="1342" actId="14100"/>
         <pc:sldMkLst>
           <pc:docMk/>
-          <pc:sldMk cId="4231616159" sldId="267"/>
-        </pc:sldMkLst>
-      </pc:sldChg>
-      <pc:sldChg chg="new del">
-        <pc:chgData name="John Gerega" userId="bd3e1e46fb6a714b" providerId="LiveId" clId="{45F0C402-C550-4C82-B31D-5B32217A5E94}" dt="2026-04-04T21:40:29.924" v="2639" actId="2696"/>
-        <pc:sldMkLst>
-          <pc:docMk/>
-          <pc:sldMk cId="2457171460" sldId="268"/>
-        </pc:sldMkLst>
-      </pc:sldChg>
-      <pc:sldChg chg="addSp delSp modSp add mod delAnim modAnim">
-        <pc:chgData name="John Gerega" userId="bd3e1e46fb6a714b" providerId="LiveId" clId="{45F0C402-C550-4C82-B31D-5B32217A5E94}" dt="2026-04-04T21:41:40.956" v="2646" actId="14100"/>
-        <pc:sldMkLst>
-          <pc:docMk/>
-          <pc:sldMk cId="2282075488" sldId="272"/>
+          <pc:sldMk cId="3713997872" sldId="259"/>
         </pc:sldMkLst>
         <pc:picChg chg="add mod">
-          <ac:chgData name="John Gerega" userId="bd3e1e46fb6a714b" providerId="LiveId" clId="{45F0C402-C550-4C82-B31D-5B32217A5E94}" dt="2026-04-04T21:41:40.956" v="2646" actId="14100"/>
+          <ac:chgData name="Margo Bonal" userId="18c9fa0f-b53d-478b-9dc0-6ad88786c19f" providerId="ADAL" clId="{93D479E5-F67F-4B8A-A78F-A0B574A116B6}" dt="2026-04-12T10:51:28.860" v="1342" actId="14100"/>
           <ac:picMkLst>
             <pc:docMk/>
-            <pc:sldMk cId="2282075488" sldId="272"/>
-            <ac:picMk id="3" creationId="{E59A6658-36B8-AE97-C67F-8DC16AF87712}"/>
+            <pc:sldMk cId="3713997872" sldId="259"/>
+            <ac:picMk id="5" creationId="{B0894097-9C9B-8B23-3BC5-11C154EBBAD5}"/>
           </ac:picMkLst>
         </pc:picChg>
         <pc:picChg chg="del">
-          <ac:chgData name="John Gerega" userId="bd3e1e46fb6a714b" providerId="LiveId" clId="{45F0C402-C550-4C82-B31D-5B32217A5E94}" dt="2026-04-04T21:41:17.826" v="2641" actId="478"/>
+          <ac:chgData name="Margo Bonal" userId="18c9fa0f-b53d-478b-9dc0-6ad88786c19f" providerId="ADAL" clId="{93D479E5-F67F-4B8A-A78F-A0B574A116B6}" dt="2026-04-12T10:50:53.798" v="1333" actId="478"/>
           <ac:picMkLst>
             <pc:docMk/>
-            <pc:sldMk cId="2282075488" sldId="272"/>
-            <ac:picMk id="5" creationId="{AD0A49AD-572F-1BD3-B96A-4F6CEBD54DC1}"/>
+            <pc:sldMk cId="3713997872" sldId="259"/>
+            <ac:picMk id="6" creationId="{0D4E0165-E852-9E37-91F6-9A7920B23AEB}"/>
           </ac:picMkLst>
         </pc:picChg>
+      </pc:sldChg>
+      <pc:sldChg chg="modSp mod">
+        <pc:chgData name="Margo Bonal" userId="18c9fa0f-b53d-478b-9dc0-6ad88786c19f" providerId="ADAL" clId="{93D479E5-F67F-4B8A-A78F-A0B574A116B6}" dt="2026-04-05T23:08:31.942" v="1065" actId="20577"/>
+        <pc:sldMkLst>
+          <pc:docMk/>
+          <pc:sldMk cId="2561402868" sldId="264"/>
+        </pc:sldMkLst>
+        <pc:spChg chg="mod">
+          <ac:chgData name="Margo Bonal" userId="18c9fa0f-b53d-478b-9dc0-6ad88786c19f" providerId="ADAL" clId="{93D479E5-F67F-4B8A-A78F-A0B574A116B6}" dt="2026-03-21T14:21:56.751" v="935" actId="27636"/>
+          <ac:spMkLst>
+            <pc:docMk/>
+            <pc:sldMk cId="2561402868" sldId="264"/>
+            <ac:spMk id="9" creationId="{D6D36DC8-D9BF-8C26-69EA-ED89E34DB644}"/>
+          </ac:spMkLst>
+        </pc:spChg>
+        <pc:graphicFrameChg chg="mod modGraphic">
+          <ac:chgData name="Margo Bonal" userId="18c9fa0f-b53d-478b-9dc0-6ad88786c19f" providerId="ADAL" clId="{93D479E5-F67F-4B8A-A78F-A0B574A116B6}" dt="2026-04-05T23:08:31.942" v="1065" actId="20577"/>
+          <ac:graphicFrameMkLst>
+            <pc:docMk/>
+            <pc:sldMk cId="2561402868" sldId="264"/>
+            <ac:graphicFrameMk id="27" creationId="{D6B93F0B-FEB0-EDAB-CFE1-A57DEFE97FCD}"/>
+          </ac:graphicFrameMkLst>
+        </pc:graphicFrameChg>
+      </pc:sldChg>
+      <pc:sldChg chg="delSp modSp mod">
+        <pc:chgData name="Margo Bonal" userId="18c9fa0f-b53d-478b-9dc0-6ad88786c19f" providerId="ADAL" clId="{93D479E5-F67F-4B8A-A78F-A0B574A116B6}" dt="2026-04-12T10:49:28.496" v="1332" actId="313"/>
+        <pc:sldMkLst>
+          <pc:docMk/>
+          <pc:sldMk cId="2428741132" sldId="265"/>
+        </pc:sldMkLst>
+        <pc:spChg chg="mod">
+          <ac:chgData name="Margo Bonal" userId="18c9fa0f-b53d-478b-9dc0-6ad88786c19f" providerId="ADAL" clId="{93D479E5-F67F-4B8A-A78F-A0B574A116B6}" dt="2026-04-12T10:49:28.496" v="1332" actId="313"/>
+          <ac:spMkLst>
+            <pc:docMk/>
+            <pc:sldMk cId="2428741132" sldId="265"/>
+            <ac:spMk id="8" creationId="{7A067979-B2B3-BD33-28AB-42AF2BBE1977}"/>
+          </ac:spMkLst>
+        </pc:spChg>
+      </pc:sldChg>
+      <pc:sldChg chg="modSp mod">
+        <pc:chgData name="Margo Bonal" userId="18c9fa0f-b53d-478b-9dc0-6ad88786c19f" providerId="ADAL" clId="{93D479E5-F67F-4B8A-A78F-A0B574A116B6}" dt="2026-04-12T10:48:33.259" v="1261" actId="20577"/>
+        <pc:sldMkLst>
+          <pc:docMk/>
+          <pc:sldMk cId="3526335932" sldId="266"/>
+        </pc:sldMkLst>
+        <pc:spChg chg="mod">
+          <ac:chgData name="Margo Bonal" userId="18c9fa0f-b53d-478b-9dc0-6ad88786c19f" providerId="ADAL" clId="{93D479E5-F67F-4B8A-A78F-A0B574A116B6}" dt="2026-03-21T14:09:48.188" v="518" actId="20577"/>
+          <ac:spMkLst>
+            <pc:docMk/>
+            <pc:sldMk cId="3526335932" sldId="266"/>
+            <ac:spMk id="3" creationId="{CCDEAB36-867D-95B6-8834-F42C5B9259D0}"/>
+          </ac:spMkLst>
+        </pc:spChg>
+        <pc:spChg chg="mod">
+          <ac:chgData name="Margo Bonal" userId="18c9fa0f-b53d-478b-9dc0-6ad88786c19f" providerId="ADAL" clId="{93D479E5-F67F-4B8A-A78F-A0B574A116B6}" dt="2026-04-12T10:48:12.135" v="1220" actId="20577"/>
+          <ac:spMkLst>
+            <pc:docMk/>
+            <pc:sldMk cId="3526335932" sldId="266"/>
+            <ac:spMk id="4" creationId="{86ED9EE4-56A8-6AFD-BE9A-A35D2ABC59A0}"/>
+          </ac:spMkLst>
+        </pc:spChg>
+        <pc:spChg chg="mod">
+          <ac:chgData name="Margo Bonal" userId="18c9fa0f-b53d-478b-9dc0-6ad88786c19f" providerId="ADAL" clId="{93D479E5-F67F-4B8A-A78F-A0B574A116B6}" dt="2026-04-12T10:48:33.259" v="1261" actId="20577"/>
+          <ac:spMkLst>
+            <pc:docMk/>
+            <pc:sldMk cId="3526335932" sldId="266"/>
+            <ac:spMk id="6" creationId="{3B13CF04-9C06-053E-69E2-58CD31C3D276}"/>
+          </ac:spMkLst>
+        </pc:spChg>
       </pc:sldChg>
     </pc:docChg>
   </pc:docChgLst>
@@ -6473,7 +6261,7 @@
           <a:p>
             <a:fld id="{B1F2A6E6-BB86-4722-837C-048EA2408876}" type="datetimeFigureOut">
               <a:rPr lang="en-US" smtClean="0"/>
-              <a:t>4/10/2026</a:t>
+              <a:t>4/12/2026</a:t>
             </a:fld>
             <a:endParaRPr lang="en-US"/>
           </a:p>
@@ -6887,7 +6675,7 @@
           <a:p>
             <a:fld id="{C882E6FB-EB88-4936-BED9-9E37159958CA}" type="datetimeFigureOut">
               <a:rPr lang="en-US" smtClean="0"/>
-              <a:t>4/10/2026</a:t>
+              <a:t>4/12/2026</a:t>
             </a:fld>
             <a:endParaRPr lang="en-US"/>
           </a:p>
@@ -7085,7 +6873,7 @@
           <a:p>
             <a:fld id="{C882E6FB-EB88-4936-BED9-9E37159958CA}" type="datetimeFigureOut">
               <a:rPr lang="en-US" smtClean="0"/>
-              <a:t>4/10/2026</a:t>
+              <a:t>4/12/2026</a:t>
             </a:fld>
             <a:endParaRPr lang="en-US"/>
           </a:p>
@@ -7293,7 +7081,7 @@
           <a:p>
             <a:fld id="{C882E6FB-EB88-4936-BED9-9E37159958CA}" type="datetimeFigureOut">
               <a:rPr lang="en-US" smtClean="0"/>
-              <a:t>4/10/2026</a:t>
+              <a:t>4/12/2026</a:t>
             </a:fld>
             <a:endParaRPr lang="en-US"/>
           </a:p>
@@ -7491,7 +7279,7 @@
           <a:p>
             <a:fld id="{C882E6FB-EB88-4936-BED9-9E37159958CA}" type="datetimeFigureOut">
               <a:rPr lang="en-US" smtClean="0"/>
-              <a:t>4/10/2026</a:t>
+              <a:t>4/12/2026</a:t>
             </a:fld>
             <a:endParaRPr lang="en-US"/>
           </a:p>
@@ -7766,7 +7554,7 @@
           <a:p>
             <a:fld id="{C882E6FB-EB88-4936-BED9-9E37159958CA}" type="datetimeFigureOut">
               <a:rPr lang="en-US" smtClean="0"/>
-              <a:t>4/10/2026</a:t>
+              <a:t>4/12/2026</a:t>
             </a:fld>
             <a:endParaRPr lang="en-US"/>
           </a:p>
@@ -8031,7 +7819,7 @@
           <a:p>
             <a:fld id="{C882E6FB-EB88-4936-BED9-9E37159958CA}" type="datetimeFigureOut">
               <a:rPr lang="en-US" smtClean="0"/>
-              <a:t>4/10/2026</a:t>
+              <a:t>4/12/2026</a:t>
             </a:fld>
             <a:endParaRPr lang="en-US"/>
           </a:p>
@@ -8443,7 +8231,7 @@
           <a:p>
             <a:fld id="{C882E6FB-EB88-4936-BED9-9E37159958CA}" type="datetimeFigureOut">
               <a:rPr lang="en-US" smtClean="0"/>
-              <a:t>4/10/2026</a:t>
+              <a:t>4/12/2026</a:t>
             </a:fld>
             <a:endParaRPr lang="en-US"/>
           </a:p>
@@ -8584,7 +8372,7 @@
           <a:p>
             <a:fld id="{C882E6FB-EB88-4936-BED9-9E37159958CA}" type="datetimeFigureOut">
               <a:rPr lang="en-US" smtClean="0"/>
-              <a:t>4/10/2026</a:t>
+              <a:t>4/12/2026</a:t>
             </a:fld>
             <a:endParaRPr lang="en-US"/>
           </a:p>
@@ -8697,7 +8485,7 @@
           <a:p>
             <a:fld id="{C882E6FB-EB88-4936-BED9-9E37159958CA}" type="datetimeFigureOut">
               <a:rPr lang="en-US" smtClean="0"/>
-              <a:t>4/10/2026</a:t>
+              <a:t>4/12/2026</a:t>
             </a:fld>
             <a:endParaRPr lang="en-US"/>
           </a:p>
@@ -9008,7 +8796,7 @@
           <a:p>
             <a:fld id="{C882E6FB-EB88-4936-BED9-9E37159958CA}" type="datetimeFigureOut">
               <a:rPr lang="en-US" smtClean="0"/>
-              <a:t>4/10/2026</a:t>
+              <a:t>4/12/2026</a:t>
             </a:fld>
             <a:endParaRPr lang="en-US"/>
           </a:p>
@@ -9296,7 +9084,7 @@
           <a:p>
             <a:fld id="{C882E6FB-EB88-4936-BED9-9E37159958CA}" type="datetimeFigureOut">
               <a:rPr lang="en-US" smtClean="0"/>
-              <a:t>4/10/2026</a:t>
+              <a:t>4/12/2026</a:t>
             </a:fld>
             <a:endParaRPr lang="en-US"/>
           </a:p>
@@ -9537,7 +9325,7 @@
           <a:p>
             <a:fld id="{C882E6FB-EB88-4936-BED9-9E37159958CA}" type="datetimeFigureOut">
               <a:rPr lang="en-US" smtClean="0"/>
-              <a:t>4/10/2026</a:t>
+              <a:t>4/12/2026</a:t>
             </a:fld>
             <a:endParaRPr lang="en-US"/>
           </a:p>
@@ -11280,8 +11068,42 @@
                   <a:schemeClr val="tx1"/>
                 </a:solidFill>
               </a:rPr>
+              <a:t>Writing Center appointment</a:t>
+            </a:r>
+          </a:p>
+          <a:p>
+            <a:pPr marL="342900" indent="-342900">
+              <a:buFont typeface="Arial" panose="020B0604020202020204" pitchFamily="34" charset="0"/>
+              <a:buChar char="•"/>
+            </a:pPr>
+            <a:r>
+              <a:rPr lang="en-US" dirty="0">
+                <a:solidFill>
+                  <a:schemeClr val="tx1"/>
+                </a:solidFill>
+              </a:rPr>
               <a:t>Finished User Manual</a:t>
             </a:r>
+          </a:p>
+          <a:p>
+            <a:pPr marL="342900" indent="-342900">
+              <a:buFont typeface="Arial" panose="020B0604020202020204" pitchFamily="34" charset="0"/>
+              <a:buChar char="•"/>
+            </a:pPr>
+            <a:r>
+              <a:rPr lang="en-US" dirty="0">
+                <a:solidFill>
+                  <a:schemeClr val="tx1"/>
+                </a:solidFill>
+              </a:rPr>
+              <a:t>Prepare manual for printing </a:t>
+            </a:r>
+          </a:p>
+          <a:p>
+            <a:pPr marL="342900" indent="-342900">
+              <a:buFont typeface="Arial" panose="020B0604020202020204" pitchFamily="34" charset="0"/>
+              <a:buChar char="•"/>
+            </a:pPr>
             <a:endParaRPr lang="en-US" dirty="0"/>
           </a:p>
           <a:p>
@@ -11616,7 +11438,21 @@
                   <a:schemeClr val="tx1"/>
                 </a:solidFill>
               </a:rPr>
-              <a:t>Writing the user manual for a project that we created.</a:t>
+              <a:t>Writing the user manual with technical and detailed steps for both users and developers to navigate.</a:t>
+            </a:r>
+          </a:p>
+          <a:p>
+            <a:pPr marL="342900" indent="-342900">
+              <a:buFont typeface="+mj-lt"/>
+              <a:buAutoNum type="arabicPeriod"/>
+            </a:pPr>
+            <a:r>
+              <a:rPr lang="en-US" sz="2000" dirty="0">
+                <a:solidFill>
+                  <a:schemeClr val="tx1"/>
+                </a:solidFill>
+              </a:rPr>
+              <a:t>Hosting Configuration speed, server reboot time far to  slow</a:t>
             </a:r>
           </a:p>
         </p:txBody>
@@ -12608,6 +12444,20 @@
               <a:t>After taking a step back and attempting to view our project as new users we found areas that needed clear instructions.</a:t>
             </a:r>
           </a:p>
+          <a:p>
+            <a:pPr marL="342900" indent="-342900">
+              <a:buFont typeface="+mj-lt"/>
+              <a:buAutoNum type="arabicPeriod"/>
+            </a:pPr>
+            <a:r>
+              <a:rPr lang="en-US" sz="2000" dirty="0">
+                <a:solidFill>
+                  <a:schemeClr val="tx1"/>
+                </a:solidFill>
+              </a:rPr>
+              <a:t>Increase # of server CPU cores </a:t>
+            </a:r>
+          </a:p>
         </p:txBody>
       </p:sp>
     </p:spTree>
@@ -13703,10 +13553,10 @@
       </p:sp>
       <p:pic>
         <p:nvPicPr>
-          <p:cNvPr id="6" name="Picture 5">
+          <p:cNvPr id="5" name="Picture 4">
             <a:extLst>
               <a:ext uri="{FF2B5EF4-FFF2-40B4-BE49-F238E27FC236}">
-                <a16:creationId xmlns:a16="http://schemas.microsoft.com/office/drawing/2014/main" id="{0D4E0165-E852-9E37-91F6-9A7920B23AEB}"/>
+                <a16:creationId xmlns:a16="http://schemas.microsoft.com/office/drawing/2014/main" id="{B0894097-9C9B-8B23-3BC5-11C154EBBAD5}"/>
               </a:ext>
             </a:extLst>
           </p:cNvPr>
@@ -13723,15 +13573,15 @@
         </p:blipFill>
         <p:spPr>
           <a:xfrm>
-            <a:off x="926432" y="2024164"/>
-            <a:ext cx="10503568" cy="4706879"/>
+            <a:off x="0" y="1929448"/>
+            <a:ext cx="12192000" cy="4928551"/>
           </a:xfrm>
           <a:prstGeom prst="rect">
             <a:avLst/>
           </a:prstGeom>
           <a:ln>
             <a:solidFill>
-              <a:schemeClr val="accent2"/>
+              <a:schemeClr val="accent1"/>
             </a:solidFill>
           </a:ln>
         </p:spPr>

</xml_diff>